<commit_message>
Jornada SDR: passagem via oportunidade no Salesforce e gerente da vertical
Co-Authored-By: Claude Opus 5.5 <noreply@anthropic.com>
Claude-Session: https://claude.ai/code/session_01Ld9Fj63CqEHYrhnAJFn4Xb
</commit_message>
<xml_diff>
--- a/ledwave-comercial/sdr/LedWave_Jornada_do_Lead_SDR.pptx
+++ b/ledwave-comercial/sdr/LedWave_Jornada_do_Lead_SDR.pptx
@@ -122,14 +122,14 @@
   <p:extLst>
     <p:ext uri="{521415D9-36F7-43E2-AB2F-B90AF26B5E84}">
       <p14:sectionLst xmlns:p14="http://schemas.microsoft.com/office/powerpoint/2010/main">
-        <p14:section name="Abertura" id="{0683c920-c275-3db4-6b23-dd3a9c2fda0b}">
+        <p14:section name="Abertura" id="{b094ea31-33db-31eb-eb93-badb7cadecec}">
           <p14:sldIdLst>
             <p14:sldId id="256"/>
             <p14:sldId id="257"/>
             <p14:sldId id="258"/>
           </p14:sldIdLst>
         </p14:section>
-        <p14:section name="Jornada" id="{db779f32-19a0-e788-9f0b-536a171d693d}">
+        <p14:section name="Jornada" id="{8f88ab93-16a4-3050-f268-20cd53d58e8f}">
           <p14:sldIdLst>
             <p14:sldId id="259"/>
             <p14:sldId id="260"/>
@@ -141,13 +141,13 @@
             <p14:sldId id="266"/>
           </p14:sldIdLst>
         </p14:section>
-        <p14:section name="Conversa" id="{af460e2a-806c-3997-416f-edc64f11dbe1}">
+        <p14:section name="Conversa" id="{2a218802-2c00-2f42-2d97-0c79fae052a0}">
           <p14:sldIdLst>
             <p14:sldId id="267"/>
             <p14:sldId id="268"/>
           </p14:sldIdLst>
         </p14:section>
-        <p14:section name="Gestão" id="{713d8bf4-c321-d59c-7a12-c0f885b08427}">
+        <p14:section name="Gestão" id="{89945d29-50cb-ec9f-a5d0-10c6f908c7e9}">
           <p14:sldIdLst>
             <p14:sldId id="269"/>
             <p14:sldId id="270"/>
@@ -558,7 +558,7 @@
           <a:p>
             <a:r>
               <a:rPr lang="en-US" dirty="0"/>
-              <a:t>Abertura: o objetivo é que todo lead seja respondido em até 5 minutos no horário comercial, qualificado em uma conversa e entregue ao executivo com tudo registrado.</a:t>
+              <a:t>Abertura: o objetivo é que todo lead seja respondido em até 5 minutos no horário comercial, qualificado em uma conversa e registrado como oportunidade no Salesforce, para o gerente da vertical indicar o executivo.</a:t>
             </a:r>
             <a:endParaRPr lang="en-US" dirty="0"/>
           </a:p>
@@ -2854,7 +2854,7 @@
                   <a:schemeClr val="tx2"/>
                 </a:solidFill>
               </a:rPr>
-              <a:t>Do primeiro contato à reunião com o executivo</a:t>
+              <a:t>Do primeiro contato à oportunidade no Salesforce</a:t>
             </a:r>
             <a:endParaRPr lang="en-US" sz="2000" dirty="0"/>
           </a:p>
@@ -2997,7 +2997,7 @@
                   <a:schemeClr val="tx1"/>
                 </a:solidFill>
               </a:rPr>
-              <a:t>Etapa 4: agendar e passar o bastão</a:t>
+              <a:t>Etapa 4: gerar a oportunidade e passar o bastão</a:t>
             </a:r>
             <a:endParaRPr lang="en-US" sz="3200" dirty="0"/>
           </a:p>
@@ -3048,7 +3048,7 @@
         <p:spPr>
           <a:xfrm>
             <a:off x="548640" y="2057400"/>
-            <a:ext cx="5394960" cy="1463040"/>
+            <a:ext cx="5394960" cy="1508760"/>
           </a:xfrm>
           <a:prstGeom prst="rect">
             <a:avLst/>
@@ -3064,14 +3064,14 @@
               <a:buNone/>
             </a:pPr>
             <a:r>
-              <a:rPr lang="en-US" sz="1600" i="1" dirty="0">
+              <a:rPr lang="en-US" sz="1500" i="1" dirty="0">
                 <a:solidFill>
                   <a:schemeClr val="tx1"/>
                 </a:solidFill>
               </a:rPr>
-              <a:t>"Faz sentido uma conversa de 30 minutos com o [executivo], nosso especialista em [nicho]. Ele mostra como ficaria no seu espaço. Terça às 10h ou quinta às 15h?"</a:t>
-            </a:r>
-            <a:endParaRPr lang="en-US" sz="1600" dirty="0"/>
+              <a:t>"Faz sentido uma conversa de 30 minutos com um especialista nosso em [nicho]. Vou registrar tudo e passar para o nosso gerente de [nicho], que indica o especialista ideal para o seu projeto. Assim você não repete nada. Qual o melhor dia e período para ele te chamar?"</a:t>
+            </a:r>
+            <a:endParaRPr lang="en-US" sz="1500" dirty="0"/>
           </a:p>
         </p:txBody>
       </p:sp>
@@ -3145,7 +3145,7 @@
                   <a:schemeClr val="tx1"/>
                 </a:solidFill>
               </a:rPr>
-              <a:t>Confirmação no WhatsApp com data, hora e formato</a:t>
+              <a:t>Gerar a oportunidade no Salesforce com a nota completa</a:t>
             </a:r>
             <a:endParaRPr lang="en-US" sz="1500" dirty="0"/>
           </a:p>
@@ -3163,7 +3163,7 @@
                   <a:schemeClr val="tx1"/>
                 </a:solidFill>
               </a:rPr>
-              <a:t>Pedir uma foto do espaço para a simulação</a:t>
+              <a:t>Passar ao gerente da vertical, que indica o executivo</a:t>
             </a:r>
             <a:endParaRPr lang="en-US" sz="1500" dirty="0"/>
           </a:p>
@@ -3181,7 +3181,7 @@
                   <a:schemeClr val="tx1"/>
                 </a:solidFill>
               </a:rPr>
-              <a:t>Lembrete na véspera e 1 hora antes</a:t>
+              <a:t>Confirmar no WhatsApp e pedir uma foto do espaço</a:t>
             </a:r>
             <a:endParaRPr lang="en-US" sz="1500" dirty="0"/>
           </a:p>
@@ -3199,7 +3199,7 @@
                   <a:schemeClr val="tx1"/>
                 </a:solidFill>
               </a:rPr>
-              <a:t>Faltou? Remarcar no mesmo dia</a:t>
+              <a:t>Acompanhar: executivo indicado e contato feito</a:t>
             </a:r>
             <a:endParaRPr lang="en-US" sz="1500" dirty="0"/>
           </a:p>
@@ -3257,7 +3257,7 @@
                   <a:schemeClr val="accent2"/>
                 </a:solidFill>
               </a:rPr>
-              <a:t>Nota de passagem no Salesforce</a:t>
+              <a:t>Nota da oportunidade no Salesforce</a:t>
             </a:r>
             <a:endParaRPr lang="en-US" sz="1800" dirty="0"/>
           </a:p>
@@ -3441,7 +3441,7 @@
                   <a:schemeClr val="bg1"/>
                 </a:solidFill>
               </a:rPr>
-              <a:t>Origem, TAG e próximo passo</a:t>
+              <a:t>Origem, TAG e melhor dia para o contato</a:t>
             </a:r>
             <a:endParaRPr lang="en-US" sz="1500" dirty="0"/>
           </a:p>
@@ -6075,7 +6075,7 @@
                   <a:schemeClr val="bg1"/>
                 </a:solidFill>
               </a:rPr>
-              <a:t>Status: Novo → Em contato → MQL → SQL → Executivo</a:t>
+              <a:t>Status: Novo → Em contato → MQL → Oportunidade (SQL) → Gerente → Executivo</a:t>
             </a:r>
             <a:endParaRPr lang="en-US" sz="1400" dirty="0"/>
           </a:p>
@@ -7933,7 +7933,7 @@
                   <a:schemeClr val="tx1"/>
                 </a:solidFill>
               </a:rPr>
-              <a:t>Responder rápido, conversar sobre o negócio do cliente e entregar ao executivo uma reunião com tudo anotado.</a:t>
+              <a:t>Responder rápido, conversar sobre o negócio do cliente e entregar ao gerente da vertical uma oportunidade com tudo anotado.</a:t>
             </a:r>
             <a:endParaRPr lang="en-US" sz="3400" dirty="0"/>
           </a:p>
@@ -8966,7 +8966,7 @@
                   <a:schemeClr val="tx2"/>
                 </a:solidFill>
               </a:rPr>
-              <a:t>O executivo vende; o SDR entende e agenda</a:t>
+              <a:t>O executivo vende; o SDR entende e gera a oportunidade</a:t>
             </a:r>
             <a:endParaRPr lang="en-US" sz="1500" dirty="0"/>
           </a:p>
@@ -9922,7 +9922,7 @@
                   <a:schemeClr val="tx1"/>
                 </a:solidFill>
               </a:rPr>
-              <a:t>Agendamento</a:t>
+              <a:t>Oportunidade</a:t>
             </a:r>
             <a:endParaRPr lang="en-US" sz="1500" dirty="0"/>
           </a:p>
@@ -9958,7 +9958,7 @@
                   <a:schemeClr val="tx2"/>
                 </a:solidFill>
               </a:rPr>
-              <a:t>reunião + nota de passagem</a:t>
+              <a:t>Salesforce + gerente da vertical</a:t>
             </a:r>
             <a:endParaRPr lang="en-US" sz="1300" dirty="0"/>
           </a:p>
@@ -10459,7 +10459,7 @@
                   <a:schemeClr val="tx1"/>
                 </a:solidFill>
               </a:rPr>
-              <a:t>o lead só sai da fila com reunião agendada ou com motivo registrado. Respondeu na cadência? Volta para a qualificação.</a:t>
+              <a:t>o lead só sai da fila como oportunidade passada ao gerente da vertical ou com motivo registrado. Respondeu na cadência? Volta para a qualificação.</a:t>
             </a:r>
             <a:endParaRPr lang="en-US" sz="1700" dirty="0"/>
           </a:p>

</xml_diff>